<commit_message>
docs: align presentation branding and history guidance
</commit_message>
<xml_diff>
--- a/docs/presentation/PulseHub-soutenance.pptx
+++ b/docs/presentation/PulseHub-soutenance.pptx
@@ -2,27 +2,27 @@
 <file path=ppt/presentation.xml><?xml version="1.0" encoding="utf-8"?>
 <p:presentation xmlns:p="http://schemas.openxmlformats.org/presentationml/2006/main">
   <p:sldMasterIdLst>
-    <p:sldMasterId xmlns:r="http://schemas.openxmlformats.org/officeDocument/2006/relationships" id="2147483648" r:id="R4467f9d0bbfd44bf"/>
+    <p:sldMasterId xmlns:r="http://schemas.openxmlformats.org/officeDocument/2006/relationships" id="2147483648" r:id="Rf0c81a42a11f4d96"/>
   </p:sldMasterIdLst>
   <p:notesMasterIdLst>
-    <p:notesMasterId xmlns:r="http://schemas.openxmlformats.org/officeDocument/2006/relationships" r:id="Rcb9ed78b997647d2"/>
+    <p:notesMasterId xmlns:r="http://schemas.openxmlformats.org/officeDocument/2006/relationships" r:id="R630f1c89f48543b2"/>
   </p:notesMasterIdLst>
   <p:sldIdLst>
-    <p:sldId xmlns:r="http://schemas.openxmlformats.org/officeDocument/2006/relationships" id="256" r:id="R74ffd5ed4dac4696"/>
-    <p:sldId xmlns:r="http://schemas.openxmlformats.org/officeDocument/2006/relationships" id="257" r:id="R6c754ea969504b50"/>
-    <p:sldId xmlns:r="http://schemas.openxmlformats.org/officeDocument/2006/relationships" id="258" r:id="Rc560a21190654ef6"/>
-    <p:sldId xmlns:r="http://schemas.openxmlformats.org/officeDocument/2006/relationships" id="259" r:id="Rd60d240467d0473f"/>
-    <p:sldId xmlns:r="http://schemas.openxmlformats.org/officeDocument/2006/relationships" id="260" r:id="R9d34b765eaef4b93"/>
-    <p:sldId xmlns:r="http://schemas.openxmlformats.org/officeDocument/2006/relationships" id="261" r:id="Rdde0573040394a97"/>
-    <p:sldId xmlns:r="http://schemas.openxmlformats.org/officeDocument/2006/relationships" id="262" r:id="Rebd7197c65db4abc"/>
-    <p:sldId xmlns:r="http://schemas.openxmlformats.org/officeDocument/2006/relationships" id="263" r:id="Re44e2b81c4864eaa"/>
-    <p:sldId xmlns:r="http://schemas.openxmlformats.org/officeDocument/2006/relationships" id="264" r:id="Rb63e76745e734180"/>
-    <p:sldId xmlns:r="http://schemas.openxmlformats.org/officeDocument/2006/relationships" id="265" r:id="Raeb13ce57dc0497d"/>
-    <p:sldId xmlns:r="http://schemas.openxmlformats.org/officeDocument/2006/relationships" id="266" r:id="R9aedd9c2512d4095"/>
-    <p:sldId xmlns:r="http://schemas.openxmlformats.org/officeDocument/2006/relationships" id="267" r:id="R2b0a7bfe1c094701"/>
-    <p:sldId xmlns:r="http://schemas.openxmlformats.org/officeDocument/2006/relationships" id="268" r:id="R93a4923561594278"/>
-    <p:sldId xmlns:r="http://schemas.openxmlformats.org/officeDocument/2006/relationships" id="269" r:id="R25f6dda27ac84ff9"/>
-    <p:sldId xmlns:r="http://schemas.openxmlformats.org/officeDocument/2006/relationships" id="270" r:id="R8b0ae5899afd420c"/>
+    <p:sldId xmlns:r="http://schemas.openxmlformats.org/officeDocument/2006/relationships" id="256" r:id="Rb8cacfc105cd457c"/>
+    <p:sldId xmlns:r="http://schemas.openxmlformats.org/officeDocument/2006/relationships" id="257" r:id="R8641958be65847e0"/>
+    <p:sldId xmlns:r="http://schemas.openxmlformats.org/officeDocument/2006/relationships" id="258" r:id="Rbbf04ce2dfb74f7b"/>
+    <p:sldId xmlns:r="http://schemas.openxmlformats.org/officeDocument/2006/relationships" id="259" r:id="Ra02933e44a5f4eeb"/>
+    <p:sldId xmlns:r="http://schemas.openxmlformats.org/officeDocument/2006/relationships" id="260" r:id="R3962a59675a242c6"/>
+    <p:sldId xmlns:r="http://schemas.openxmlformats.org/officeDocument/2006/relationships" id="261" r:id="R894113af792d4c9e"/>
+    <p:sldId xmlns:r="http://schemas.openxmlformats.org/officeDocument/2006/relationships" id="262" r:id="R79f1a28071a049ea"/>
+    <p:sldId xmlns:r="http://schemas.openxmlformats.org/officeDocument/2006/relationships" id="263" r:id="R666ad578d3844613"/>
+    <p:sldId xmlns:r="http://schemas.openxmlformats.org/officeDocument/2006/relationships" id="264" r:id="R62842d04c3444fb2"/>
+    <p:sldId xmlns:r="http://schemas.openxmlformats.org/officeDocument/2006/relationships" id="265" r:id="R64557c5022d44736"/>
+    <p:sldId xmlns:r="http://schemas.openxmlformats.org/officeDocument/2006/relationships" id="266" r:id="R522c9c28d4ba42c6"/>
+    <p:sldId xmlns:r="http://schemas.openxmlformats.org/officeDocument/2006/relationships" id="267" r:id="Rcb1a246ed64b4d17"/>
+    <p:sldId xmlns:r="http://schemas.openxmlformats.org/officeDocument/2006/relationships" id="268" r:id="R5eb14954f37241d0"/>
+    <p:sldId xmlns:r="http://schemas.openxmlformats.org/officeDocument/2006/relationships" id="269" r:id="Rf597a321c0834999"/>
+    <p:sldId xmlns:r="http://schemas.openxmlformats.org/officeDocument/2006/relationships" id="270" r:id="R1a8f5cdab5cb432a"/>
   </p:sldIdLst>
   <p:sldSz cx="12192000" cy="6858000"/>
   <p:notesSz cx="6858000" cy="9144000"/>
@@ -566,7 +566,7 @@
           </a:p>
           <a:p xmlns:a="http://schemas.openxmlformats.org/drawingml/2006/main">
             <a:r>
-              <a:t>Le projet implémente les six pistes de bonus du sujet. La chaîne JSON choisit filtres, agrégations et alertes, avec des factories enregistrées pour ajouter un type. Les règles d’alerte intègrent une durée. L’historique JSONL se relit après un redémarrage, avec deux fichiers bornés à 10 Mio chacun. Le séquenceur gère le wrap uint32 et confirme les redémarrages. Le benchmark distingue débit UDP et calcul métier isolé. La CI exécute lint, TypeScript strict, tests et compilation sur Linux et Windows. Les 39 tests couvrent entre autres le décodeur, les seuils temporels, les vrais sockets UDP/HTTP/SSE, les scénarios interactifs et le CLI. Le nombre de tests ne remplace pas une explication de leur portée. Montrer le premier test de protocole et un test de fraîcheur avec horloge injectée si demandé.</a:t>
+              <a:t>Le projet implémente les six pistes de bonus du sujet. La chaîne JSON choisit filtres, agrégations et alertes, avec des factories enregistrées pour ajouter un type. Les règles d’alerte intègrent une durée. L’historique JSONL se relit après un redémarrage, avec deux fichiers bornés à 10 Mio chacun. Le séquenceur gère le wrap uint32 et confirme les redémarrages. Le benchmark distingue débit UDP et calcul métier isolé. La CI exécute lint, TypeScript strict, tests et compilation sur Linux et Windows. Les 43 tests couvrent entre autres le décodeur, les seuils temporels, les vrais sockets UDP/HTTP/SSE, les scénarios interactifs et le CLI. Les nouveaux tests couvrent les archives au-delà de 120 relevés, les trous temporels, la tolérance, les dates invalides et la compatibilité du CLI. Le nombre de tests ne remplace pas une explication de leur portée. Montrer le premier test de protocole et un test de fraîcheur avec horloge injectée si demandé.</a:t>
             </a:r>
           </a:p>
           <a:p xmlns:a="http://schemas.openxmlformats.org/drawingml/2006/main">
@@ -581,27 +581,27 @@
           </a:p>
           <a:p xmlns:a="http://schemas.openxmlformats.org/drawingml/2006/main">
             <a:r>
-              <a:t>https://github.com/sebgrtd/rattrapage/blob/2cd5d183686c8dc2d7c5c25b3c61ea975c7d5915/README.md</a:t>
-            </a:r>
-          </a:p>
-          <a:p xmlns:a="http://schemas.openxmlformats.org/drawingml/2006/main">
-            <a:r>
-              <a:t>https://github.com/sebgrtd/rattrapage/blob/2cd5d183686c8dc2d7c5c25b3c61ea975c7d5915/test/protocol.test.ts</a:t>
-            </a:r>
-          </a:p>
-          <a:p xmlns:a="http://schemas.openxmlformats.org/drawingml/2006/main">
-            <a:r>
-              <a:t>https://github.com/sebgrtd/rattrapage/blob/2cd5d183686c8dc2d7c5c25b3c61ea975c7d5915/test/fleet.test.ts</a:t>
-            </a:r>
-          </a:p>
-          <a:p xmlns:a="http://schemas.openxmlformats.org/drawingml/2006/main">
-            <a:r>
-              <a:t>https://github.com/sebgrtd/rattrapage/blob/2cd5d183686c8dc2d7c5c25b3c61ea975c7d5915/test/demo.test.ts</a:t>
-            </a:r>
-          </a:p>
-          <a:p xmlns:a="http://schemas.openxmlformats.org/drawingml/2006/main">
-            <a:r>
-              <a:t>https://github.com/sebgrtd/rattrapage/blob/2cd5d183686c8dc2d7c5c25b3c61ea975c7d5915/.github/workflows/ci.yml</a:t>
+              <a:t>https://github.com/sebgrtd/rattrapage/blob/b3557dd6c013ff89625ad85fe5de3f6a4becc212/README.md</a:t>
+            </a:r>
+          </a:p>
+          <a:p xmlns:a="http://schemas.openxmlformats.org/drawingml/2006/main">
+            <a:r>
+              <a:t>https://github.com/sebgrtd/rattrapage/blob/b3557dd6c013ff89625ad85fe5de3f6a4becc212/test/protocol.test.ts</a:t>
+            </a:r>
+          </a:p>
+          <a:p xmlns:a="http://schemas.openxmlformats.org/drawingml/2006/main">
+            <a:r>
+              <a:t>https://github.com/sebgrtd/rattrapage/blob/b3557dd6c013ff89625ad85fe5de3f6a4becc212/test/fleet.test.ts</a:t>
+            </a:r>
+          </a:p>
+          <a:p xmlns:a="http://schemas.openxmlformats.org/drawingml/2006/main">
+            <a:r>
+              <a:t>https://github.com/sebgrtd/rattrapage/blob/b3557dd6c013ff89625ad85fe5de3f6a4becc212/test/demo.test.ts</a:t>
+            </a:r>
+          </a:p>
+          <a:p xmlns:a="http://schemas.openxmlformats.org/drawingml/2006/main">
+            <a:r>
+              <a:t>https://github.com/sebgrtd/rattrapage/blob/b3557dd6c013ff89625ad85fe5de3f6a4becc212/.github/workflows/ci.yml</a:t>
             </a:r>
           </a:p>
         </p:txBody>
@@ -1746,7 +1746,7 @@
           </a:p>
           <a:p xmlns:a="http://schemas.openxmlformats.org/drawingml/2006/main">
             <a:r>
-              <a:t>La vue globale répond à deux questions : où intervenir et peut-on faire confiance aux mesures ? Les compteurs de flotte et les points d’attention montrent les appareils concernés. La réception distingue invalides, pertes estimées et duplications ou retards. La table complète permet de rechercher un identifiant, de filtrer les états et de lire les moyennes. Le navigateur reçoit une synthèse SSE toutes les 500 ms, tandis que le hub traite toutes les trames. Consulter l’historique affiche un instantané explicite sans arrêter la réception. Cette capture provient de la démo interactive : PH-007 est hors ligne et PH-009 est en alerte. Les valeurs de cette image sont figées, le vrai dashboard reste dynamique.</a:t>
+              <a:t>La vue globale répond à deux questions : où intervenir et peut-on faire confiance aux mesures ? Les compteurs de flotte et les points d’attention montrent les appareils concernés. La réception distingue invalides, pertes estimées et duplications ou retards. La table complète permet de rechercher un identifiant, de filtrer les états et de lire les moyennes. Le navigateur reçoit une synthèse SSE toutes les 500 ms, tandis que le hub traite toutes les trames. Le calendrier et les champs de date et d’heure recherchent dans tous les relevés encore conservés. Avec un enregistrement toutes les 5 secondes, la tolérance vaut ±2,5 secondes. Le panneau montre l’heure réelle et le décalage, sans interpolation. Sans relevé assez proche, il affiche une absence de données. Le tableau historique remonte en premier. La réception continue pendant la consultation. Cette capture provient de la démo interactive : PH-007 est hors ligne et PH-009 est en alerte. Les valeurs de cette image sont figées, le vrai dashboard reste dynamique.</a:t>
             </a:r>
           </a:p>
           <a:p xmlns:a="http://schemas.openxmlformats.org/drawingml/2006/main">
@@ -1761,17 +1761,17 @@
           </a:p>
           <a:p xmlns:a="http://schemas.openxmlformats.org/drawingml/2006/main">
             <a:r>
-              <a:t>https://github.com/sebgrtd/rattrapage/blob/2cd5d183686c8dc2d7c5c25b3c61ea975c7d5915/docs/dashboard.png</a:t>
-            </a:r>
-          </a:p>
-          <a:p xmlns:a="http://schemas.openxmlformats.org/drawingml/2006/main">
-            <a:r>
-              <a:t>https://github.com/sebgrtd/rattrapage/blob/2cd5d183686c8dc2d7c5c25b3c61ea975c7d5915/public/app.js</a:t>
-            </a:r>
-          </a:p>
-          <a:p xmlns:a="http://schemas.openxmlformats.org/drawingml/2006/main">
-            <a:r>
-              <a:t>https://github.com/sebgrtd/rattrapage/blob/2cd5d183686c8dc2d7c5c25b3c61ea975c7d5915/src/server.ts</a:t>
+              <a:t>https://github.com/sebgrtd/rattrapage/blob/b3557dd6c013ff89625ad85fe5de3f6a4becc212/docs/dashboard.png</a:t>
+            </a:r>
+          </a:p>
+          <a:p xmlns:a="http://schemas.openxmlformats.org/drawingml/2006/main">
+            <a:r>
+              <a:t>https://github.com/sebgrtd/rattrapage/blob/b3557dd6c013ff89625ad85fe5de3f6a4becc212/public/app.js</a:t>
+            </a:r>
+          </a:p>
+          <a:p xmlns:a="http://schemas.openxmlformats.org/drawingml/2006/main">
+            <a:r>
+              <a:t>https://github.com/sebgrtd/rattrapage/blob/b3557dd6c013ff89625ad85fe5de3f6a4becc212/src/server.ts</a:t>
             </a:r>
           </a:p>
         </p:txBody>
@@ -1976,22 +1976,22 @@
           </a:p>
           <a:p xmlns:a="http://schemas.openxmlformats.org/drawingml/2006/main">
             <a:r>
-              <a:t>https://github.com/sebgrtd/rattrapage/blob/2cd5d183686c8dc2d7c5c25b3c61ea975c7d5915/docs/demo-interactive.md</a:t>
-            </a:r>
-          </a:p>
-          <a:p xmlns:a="http://schemas.openxmlformats.org/drawingml/2006/main">
-            <a:r>
-              <a:t>https://github.com/sebgrtd/rattrapage/blob/2cd5d183686c8dc2d7c5c25b3c61ea975c7d5915/docs/demo-interactive.png</a:t>
-            </a:r>
-          </a:p>
-          <a:p xmlns:a="http://schemas.openxmlformats.org/drawingml/2006/main">
-            <a:r>
-              <a:t>https://github.com/sebgrtd/rattrapage/blob/2cd5d183686c8dc2d7c5c25b3c61ea975c7d5915/src/demo/server.ts</a:t>
-            </a:r>
-          </a:p>
-          <a:p xmlns:a="http://schemas.openxmlformats.org/drawingml/2006/main">
-            <a:r>
-              <a:t>https://github.com/sebgrtd/rattrapage/blob/2cd5d183686c8dc2d7c5c25b3c61ea975c7d5915/src/simulator.ts</a:t>
+              <a:t>https://github.com/sebgrtd/rattrapage/blob/b3557dd6c013ff89625ad85fe5de3f6a4becc212/docs/demo-interactive.md</a:t>
+            </a:r>
+          </a:p>
+          <a:p xmlns:a="http://schemas.openxmlformats.org/drawingml/2006/main">
+            <a:r>
+              <a:t>https://github.com/sebgrtd/rattrapage/blob/b3557dd6c013ff89625ad85fe5de3f6a4becc212/docs/demo-interactive.png</a:t>
+            </a:r>
+          </a:p>
+          <a:p xmlns:a="http://schemas.openxmlformats.org/drawingml/2006/main">
+            <a:r>
+              <a:t>https://github.com/sebgrtd/rattrapage/blob/b3557dd6c013ff89625ad85fe5de3f6a4becc212/src/demo/server.ts</a:t>
+            </a:r>
+          </a:p>
+          <a:p xmlns:a="http://schemas.openxmlformats.org/drawingml/2006/main">
+            <a:r>
+              <a:t>https://github.com/sebgrtd/rattrapage/blob/b3557dd6c013ff89625ad85fe5de3f6a4becc212/src/simulator.ts</a:t>
             </a:r>
           </a:p>
         </p:txBody>
@@ -2059,7 +2059,7 @@
   </p:cSld>
   <p:clrMap bg1="lt1" tx1="dk1" bg2="lt2" tx2="dk2" accent1="accent1" accent2="accent2" accent3="accent3" accent4="accent4" accent5="accent5" accent6="accent6" hlink="hlink" folHlink="folHlink"/>
   <p:sldLayoutIdLst>
-    <p:sldLayoutId xmlns:r="http://schemas.openxmlformats.org/officeDocument/2006/relationships" id="2147483649" r:id="R21b65318622a4723"/>
+    <p:sldLayoutId xmlns:r="http://schemas.openxmlformats.org/officeDocument/2006/relationships" id="2147483649" r:id="Rbcc53fe5add34f56"/>
   </p:sldLayoutIdLst>
   <p:txStyles>
     <p:titleStyle>
@@ -2944,6 +2944,7 @@
           <a:lstStyle xmlns:a="http://schemas.openxmlformats.org/drawingml/2006/main"/>
           <a:p xmlns:a="http://schemas.openxmlformats.org/drawingml/2006/main">
             <a:pPr algn="r">
+              <a:buNone/>
               <a:defRPr sz="1425" b="0">
                 <a:solidFill>
                   <a:srgbClr val="B3B3B3"/>
@@ -2984,7 +2985,7 @@
         <p:spPr>
           <a:xfrm xmlns:a="http://schemas.openxmlformats.org/drawingml/2006/main">
             <a:off x="609600" y="1762125"/>
-            <a:ext cx="3295650" cy="1409700"/>
+            <a:ext cx="4762500" cy="1409700"/>
           </a:xfrm>
           <a:prstGeom xmlns:a="http://schemas.openxmlformats.org/drawingml/2006/main" prst="rect">
             <a:avLst/>
@@ -3001,7 +3002,8 @@
           <a:lstStyle xmlns:a="http://schemas.openxmlformats.org/drawingml/2006/main"/>
           <a:p xmlns:a="http://schemas.openxmlformats.org/drawingml/2006/main">
             <a:pPr>
-              <a:defRPr sz="9000" b="1">
+              <a:buNone/>
+              <a:defRPr sz="9000" b="0">
                 <a:solidFill>
                   <a:srgbClr val="FFFFFF"/>
                 </a:solidFill>
@@ -3011,7 +3013,7 @@
               </a:defRPr>
             </a:pPr>
             <a:r>
-              <a:rPr sz="9000" b="1">
+              <a:rPr sz="9000" b="0">
                 <a:solidFill>
                   <a:srgbClr val="FFFFFF"/>
                 </a:solidFill>
@@ -3019,7 +3021,7 @@
                 <a:ea typeface="Arial"/>
                 <a:cs typeface="Arial"/>
               </a:rPr>
-              <a:t>Pulse</a:t>
+              <a:t>pulsehub</a:t>
             </a:r>
           </a:p>
         </p:txBody>
@@ -3040,29 +3042,28 @@
         </p:nvSpPr>
         <p:spPr>
           <a:xfrm xmlns:a="http://schemas.openxmlformats.org/drawingml/2006/main">
-            <a:off x="3905250" y="1762125"/>
-            <a:ext cx="2409825" cy="1409700"/>
+            <a:off x="5276850" y="1762125"/>
+            <a:ext cx="571500" cy="1409700"/>
           </a:xfrm>
           <a:prstGeom xmlns:a="http://schemas.openxmlformats.org/drawingml/2006/main" prst="rect">
             <a:avLst/>
           </a:prstGeom>
-          <a:solidFill xmlns:a="http://schemas.openxmlformats.org/drawingml/2006/main">
-            <a:srgbClr val="FF9900"/>
-          </a:solidFill>
+          <a:noFill xmlns:a="http://schemas.openxmlformats.org/drawingml/2006/main"/>
           <a:ln xmlns:a="http://schemas.openxmlformats.org/drawingml/2006/main" w="0">
             <a:noFill/>
           </a:ln>
         </p:spPr>
         <p:txBody>
-          <a:bodyPr xmlns:a="http://schemas.openxmlformats.org/drawingml/2006/main" wrap="square" lIns="0" tIns="0" rIns="0" bIns="0" anchor="ctr">
+          <a:bodyPr xmlns:a="http://schemas.openxmlformats.org/drawingml/2006/main" wrap="square" lIns="0" tIns="0" rIns="0" bIns="0" anchor="t">
             <a:noAutofit/>
           </a:bodyPr>
           <a:lstStyle xmlns:a="http://schemas.openxmlformats.org/drawingml/2006/main"/>
           <a:p xmlns:a="http://schemas.openxmlformats.org/drawingml/2006/main">
-            <a:pPr algn="ctr">
-              <a:defRPr sz="9000" b="1">
-                <a:solidFill>
-                  <a:srgbClr val="000000"/>
+            <a:pPr algn="l">
+              <a:buNone/>
+              <a:defRPr sz="9000" b="0">
+                <a:solidFill>
+                  <a:srgbClr val="FF9900"/>
                 </a:solidFill>
                 <a:latin typeface="Arial"/>
                 <a:ea typeface="Arial"/>
@@ -3070,15 +3071,15 @@
               </a:defRPr>
             </a:pPr>
             <a:r>
-              <a:rPr sz="9000" b="1">
-                <a:solidFill>
-                  <a:srgbClr val="000000"/>
+              <a:rPr sz="9000" b="0">
+                <a:solidFill>
+                  <a:srgbClr val="FF9900"/>
                 </a:solidFill>
                 <a:latin typeface="Arial"/>
                 <a:ea typeface="Arial"/>
                 <a:cs typeface="Arial"/>
               </a:rPr>
-              <a:t>Hub</a:t>
+              <a:t>.</a:t>
             </a:r>
           </a:p>
         </p:txBody>
@@ -3117,6 +3118,7 @@
           <a:lstStyle xmlns:a="http://schemas.openxmlformats.org/drawingml/2006/main"/>
           <a:p xmlns:a="http://schemas.openxmlformats.org/drawingml/2006/main">
             <a:pPr>
+              <a:buNone/>
               <a:defRPr sz="3150" b="0">
                 <a:solidFill>
                   <a:srgbClr val="FFFFFF"/>
@@ -3174,6 +3176,7 @@
           <a:lstStyle xmlns:a="http://schemas.openxmlformats.org/drawingml/2006/main"/>
           <a:p xmlns:a="http://schemas.openxmlformats.org/drawingml/2006/main">
             <a:pPr>
+              <a:buNone/>
               <a:defRPr sz="2025" b="0">
                 <a:solidFill>
                   <a:srgbClr val="B3B3B3"/>
@@ -3197,6 +3200,7 @@
           </a:p>
           <a:p xmlns:a="http://schemas.openxmlformats.org/drawingml/2006/main">
             <a:pPr>
+              <a:buNone/>
               <a:defRPr sz="2025" b="0">
                 <a:solidFill>
                   <a:srgbClr val="B3B3B3"/>
@@ -3254,6 +3258,7 @@
           <a:lstStyle xmlns:a="http://schemas.openxmlformats.org/drawingml/2006/main"/>
           <a:p xmlns:a="http://schemas.openxmlformats.org/drawingml/2006/main">
             <a:pPr>
+              <a:buNone/>
               <a:defRPr sz="1725" b="0">
                 <a:solidFill>
                   <a:srgbClr val="FF9900"/>
@@ -3340,6 +3345,7 @@
           <a:lstStyle xmlns:a="http://schemas.openxmlformats.org/drawingml/2006/main"/>
           <a:p xmlns:a="http://schemas.openxmlformats.org/drawingml/2006/main">
             <a:pPr>
+              <a:buNone/>
               <a:defRPr sz="3300" b="1">
                 <a:solidFill>
                   <a:srgbClr val="FFFFFF"/>
@@ -3397,6 +3403,7 @@
           <a:lstStyle xmlns:a="http://schemas.openxmlformats.org/drawingml/2006/main"/>
           <a:p xmlns:a="http://schemas.openxmlformats.org/drawingml/2006/main">
             <a:pPr algn="r">
+              <a:buNone/>
               <a:defRPr sz="1425" b="0">
                 <a:solidFill>
                   <a:srgbClr val="B3B3B3"/>
@@ -3454,6 +3461,7 @@
           <a:lstStyle xmlns:a="http://schemas.openxmlformats.org/drawingml/2006/main"/>
           <a:p xmlns:a="http://schemas.openxmlformats.org/drawingml/2006/main">
             <a:pPr>
+              <a:buNone/>
               <a:defRPr sz="10950" b="1">
                 <a:solidFill>
                   <a:srgbClr val="FF9900"/>
@@ -3472,7 +3480,7 @@
                 <a:ea typeface="Arial"/>
                 <a:cs typeface="Arial"/>
               </a:rPr>
-              <a:t>39</a:t>
+              <a:t>43</a:t>
             </a:r>
           </a:p>
         </p:txBody>
@@ -3511,6 +3519,7 @@
           <a:lstStyle xmlns:a="http://schemas.openxmlformats.org/drawingml/2006/main"/>
           <a:p xmlns:a="http://schemas.openxmlformats.org/drawingml/2006/main">
             <a:pPr>
+              <a:buNone/>
               <a:defRPr sz="3225" b="0">
                 <a:solidFill>
                   <a:srgbClr val="FFFFFF"/>
@@ -3568,6 +3577,7 @@
           <a:lstStyle xmlns:a="http://schemas.openxmlformats.org/drawingml/2006/main"/>
           <a:p xmlns:a="http://schemas.openxmlformats.org/drawingml/2006/main">
             <a:pPr>
+              <a:buNone/>
               <a:defRPr sz="2175" b="0">
                 <a:solidFill>
                   <a:srgbClr val="B3B3B3"/>
@@ -3591,6 +3601,7 @@
           </a:p>
           <a:p xmlns:a="http://schemas.openxmlformats.org/drawingml/2006/main">
             <a:pPr>
+              <a:buNone/>
               <a:defRPr sz="2175" b="0">
                 <a:solidFill>
                   <a:srgbClr val="B3B3B3"/>
@@ -3614,6 +3625,7 @@
           </a:p>
           <a:p xmlns:a="http://schemas.openxmlformats.org/drawingml/2006/main">
             <a:pPr>
+              <a:buNone/>
               <a:defRPr sz="2175" b="0">
                 <a:solidFill>
                   <a:srgbClr val="B3B3B3"/>
@@ -3671,6 +3683,7 @@
           <a:lstStyle xmlns:a="http://schemas.openxmlformats.org/drawingml/2006/main"/>
           <a:p xmlns:a="http://schemas.openxmlformats.org/drawingml/2006/main">
             <a:pPr>
+              <a:buNone/>
               <a:defRPr sz="1950" b="0">
                 <a:solidFill>
                   <a:srgbClr val="FF9900"/>
@@ -3728,6 +3741,7 @@
           <a:lstStyle xmlns:a="http://schemas.openxmlformats.org/drawingml/2006/main"/>
           <a:p xmlns:a="http://schemas.openxmlformats.org/drawingml/2006/main">
             <a:pPr>
+              <a:buNone/>
               <a:defRPr sz="2250" b="0">
                 <a:solidFill>
                   <a:srgbClr val="FFFFFF"/>
@@ -3785,6 +3799,7 @@
           <a:lstStyle xmlns:a="http://schemas.openxmlformats.org/drawingml/2006/main"/>
           <a:p xmlns:a="http://schemas.openxmlformats.org/drawingml/2006/main">
             <a:pPr>
+              <a:buNone/>
               <a:defRPr sz="1950" b="0">
                 <a:solidFill>
                   <a:srgbClr val="FF9900"/>
@@ -3842,6 +3857,7 @@
           <a:lstStyle xmlns:a="http://schemas.openxmlformats.org/drawingml/2006/main"/>
           <a:p xmlns:a="http://schemas.openxmlformats.org/drawingml/2006/main">
             <a:pPr>
+              <a:buNone/>
               <a:defRPr sz="2250" b="0">
                 <a:solidFill>
                   <a:srgbClr val="FFFFFF"/>
@@ -3899,6 +3915,7 @@
           <a:lstStyle xmlns:a="http://schemas.openxmlformats.org/drawingml/2006/main"/>
           <a:p xmlns:a="http://schemas.openxmlformats.org/drawingml/2006/main">
             <a:pPr>
+              <a:buNone/>
               <a:defRPr sz="1950" b="0">
                 <a:solidFill>
                   <a:srgbClr val="FF9900"/>
@@ -3956,6 +3973,7 @@
           <a:lstStyle xmlns:a="http://schemas.openxmlformats.org/drawingml/2006/main"/>
           <a:p xmlns:a="http://schemas.openxmlformats.org/drawingml/2006/main">
             <a:pPr>
+              <a:buNone/>
               <a:defRPr sz="2250" b="0">
                 <a:solidFill>
                   <a:srgbClr val="FFFFFF"/>
@@ -4013,6 +4031,7 @@
           <a:lstStyle xmlns:a="http://schemas.openxmlformats.org/drawingml/2006/main"/>
           <a:p xmlns:a="http://schemas.openxmlformats.org/drawingml/2006/main">
             <a:pPr>
+              <a:buNone/>
               <a:defRPr sz="1950" b="0">
                 <a:solidFill>
                   <a:srgbClr val="FF9900"/>
@@ -4070,6 +4089,7 @@
           <a:lstStyle xmlns:a="http://schemas.openxmlformats.org/drawingml/2006/main"/>
           <a:p xmlns:a="http://schemas.openxmlformats.org/drawingml/2006/main">
             <a:pPr>
+              <a:buNone/>
               <a:defRPr sz="2250" b="0">
                 <a:solidFill>
                   <a:srgbClr val="FFFFFF"/>
@@ -4127,6 +4147,7 @@
           <a:lstStyle xmlns:a="http://schemas.openxmlformats.org/drawingml/2006/main"/>
           <a:p xmlns:a="http://schemas.openxmlformats.org/drawingml/2006/main">
             <a:pPr>
+              <a:buNone/>
               <a:defRPr sz="1950" b="0">
                 <a:solidFill>
                   <a:srgbClr val="FF9900"/>
@@ -4184,6 +4205,7 @@
           <a:lstStyle xmlns:a="http://schemas.openxmlformats.org/drawingml/2006/main"/>
           <a:p xmlns:a="http://schemas.openxmlformats.org/drawingml/2006/main">
             <a:pPr>
+              <a:buNone/>
               <a:defRPr sz="2250" b="0">
                 <a:solidFill>
                   <a:srgbClr val="FFFFFF"/>
@@ -4241,6 +4263,7 @@
           <a:lstStyle xmlns:a="http://schemas.openxmlformats.org/drawingml/2006/main"/>
           <a:p xmlns:a="http://schemas.openxmlformats.org/drawingml/2006/main">
             <a:pPr>
+              <a:buNone/>
               <a:defRPr sz="1950" b="0">
                 <a:solidFill>
                   <a:srgbClr val="FF9900"/>
@@ -4298,6 +4321,7 @@
           <a:lstStyle xmlns:a="http://schemas.openxmlformats.org/drawingml/2006/main"/>
           <a:p xmlns:a="http://schemas.openxmlformats.org/drawingml/2006/main">
             <a:pPr>
+              <a:buNone/>
               <a:defRPr sz="2250" b="0">
                 <a:solidFill>
                   <a:srgbClr val="FFFFFF"/>
@@ -4384,6 +4408,7 @@
           <a:lstStyle xmlns:a="http://schemas.openxmlformats.org/drawingml/2006/main"/>
           <a:p xmlns:a="http://schemas.openxmlformats.org/drawingml/2006/main">
             <a:pPr>
+              <a:buNone/>
               <a:defRPr sz="3300" b="1">
                 <a:solidFill>
                   <a:srgbClr val="FFFFFF"/>
@@ -4441,6 +4466,7 @@
           <a:lstStyle xmlns:a="http://schemas.openxmlformats.org/drawingml/2006/main"/>
           <a:p xmlns:a="http://schemas.openxmlformats.org/drawingml/2006/main">
             <a:pPr algn="r">
+              <a:buNone/>
               <a:defRPr sz="1425" b="0">
                 <a:solidFill>
                   <a:srgbClr val="B3B3B3"/>
@@ -4466,7 +4492,7 @@
       </p:sp>
       <p:graphicFrame>
         <p:nvGraphicFramePr>
-          <p:cNvPr id="11" name="Chart"/>
+          <p:cNvPr id="13" name="Chart"/>
           <p:cNvGraphicFramePr/>
           <p:nvPr/>
         </p:nvGraphicFramePr>
@@ -4476,7 +4502,7 @@
         </p:xfrm>
         <a:graphic xmlns:a="http://schemas.openxmlformats.org/drawingml/2006/main">
           <a:graphicData uri="http://schemas.openxmlformats.org/drawingml/2006/chart">
-            <c:chart xmlns:r="http://schemas.openxmlformats.org/officeDocument/2006/relationships" xmlns:c="http://schemas.openxmlformats.org/drawingml/2006/chart" r:id="Rbb88e09e3eb84df1"/>
+            <c:chart xmlns:r="http://schemas.openxmlformats.org/officeDocument/2006/relationships" xmlns:c="http://schemas.openxmlformats.org/drawingml/2006/chart" r:id="Rf18be7d33fb04c08"/>
           </a:graphicData>
         </a:graphic>
       </p:graphicFrame>
@@ -4514,6 +4540,7 @@
           <a:lstStyle xmlns:a="http://schemas.openxmlformats.org/drawingml/2006/main"/>
           <a:p xmlns:a="http://schemas.openxmlformats.org/drawingml/2006/main">
             <a:pPr>
+              <a:buNone/>
               <a:defRPr sz="5175" b="1">
                 <a:solidFill>
                   <a:srgbClr val="FF9900"/>
@@ -4571,6 +4598,7 @@
           <a:lstStyle xmlns:a="http://schemas.openxmlformats.org/drawingml/2006/main"/>
           <a:p xmlns:a="http://schemas.openxmlformats.org/drawingml/2006/main">
             <a:pPr>
+              <a:buNone/>
               <a:defRPr sz="2025" b="0">
                 <a:solidFill>
                   <a:srgbClr val="FFFFFF"/>
@@ -4594,6 +4622,7 @@
           </a:p>
           <a:p xmlns:a="http://schemas.openxmlformats.org/drawingml/2006/main">
             <a:pPr>
+              <a:buNone/>
               <a:defRPr sz="2025" b="0">
                 <a:solidFill>
                   <a:srgbClr val="FFFFFF"/>
@@ -4651,6 +4680,7 @@
           <a:lstStyle xmlns:a="http://schemas.openxmlformats.org/drawingml/2006/main"/>
           <a:p xmlns:a="http://schemas.openxmlformats.org/drawingml/2006/main">
             <a:pPr>
+              <a:buNone/>
               <a:defRPr sz="3375" b="1">
                 <a:solidFill>
                   <a:srgbClr val="FFFFFF"/>
@@ -4708,6 +4738,7 @@
           <a:lstStyle xmlns:a="http://schemas.openxmlformats.org/drawingml/2006/main"/>
           <a:p xmlns:a="http://schemas.openxmlformats.org/drawingml/2006/main">
             <a:pPr>
+              <a:buNone/>
               <a:defRPr sz="1875" b="0">
                 <a:solidFill>
                   <a:srgbClr val="B3B3B3"/>
@@ -4731,6 +4762,7 @@
           </a:p>
           <a:p xmlns:a="http://schemas.openxmlformats.org/drawingml/2006/main">
             <a:pPr>
+              <a:buNone/>
               <a:defRPr sz="1875" b="0">
                 <a:solidFill>
                   <a:srgbClr val="B3B3B3"/>
@@ -4788,6 +4820,7 @@
           <a:lstStyle xmlns:a="http://schemas.openxmlformats.org/drawingml/2006/main"/>
           <a:p xmlns:a="http://schemas.openxmlformats.org/drawingml/2006/main">
             <a:pPr>
+              <a:buNone/>
               <a:defRPr sz="1575" b="0">
                 <a:solidFill>
                   <a:srgbClr val="B3B3B3"/>
@@ -4811,6 +4844,7 @@
           </a:p>
           <a:p xmlns:a="http://schemas.openxmlformats.org/drawingml/2006/main">
             <a:pPr>
+              <a:buNone/>
               <a:defRPr sz="1575" b="0">
                 <a:solidFill>
                   <a:srgbClr val="B3B3B3"/>
@@ -4897,6 +4931,7 @@
           <a:lstStyle xmlns:a="http://schemas.openxmlformats.org/drawingml/2006/main"/>
           <a:p xmlns:a="http://schemas.openxmlformats.org/drawingml/2006/main">
             <a:pPr>
+              <a:buNone/>
               <a:defRPr sz="3300" b="1">
                 <a:solidFill>
                   <a:srgbClr val="FFFFFF"/>
@@ -4954,6 +4989,7 @@
           <a:lstStyle xmlns:a="http://schemas.openxmlformats.org/drawingml/2006/main"/>
           <a:p xmlns:a="http://schemas.openxmlformats.org/drawingml/2006/main">
             <a:pPr algn="r">
+              <a:buNone/>
               <a:defRPr sz="1425" b="0">
                 <a:solidFill>
                   <a:srgbClr val="B3B3B3"/>
@@ -5011,6 +5047,7 @@
           <a:lstStyle xmlns:a="http://schemas.openxmlformats.org/drawingml/2006/main"/>
           <a:p xmlns:a="http://schemas.openxmlformats.org/drawingml/2006/main">
             <a:pPr>
+              <a:buNone/>
               <a:defRPr sz="2400" b="1">
                 <a:solidFill>
                   <a:srgbClr val="FF9900"/>
@@ -5068,6 +5105,7 @@
           <a:lstStyle xmlns:a="http://schemas.openxmlformats.org/drawingml/2006/main"/>
           <a:p xmlns:a="http://schemas.openxmlformats.org/drawingml/2006/main">
             <a:pPr>
+              <a:buNone/>
               <a:defRPr sz="2325" b="0">
                 <a:solidFill>
                   <a:srgbClr val="FFFFFF"/>
@@ -5125,6 +5163,7 @@
           <a:lstStyle xmlns:a="http://schemas.openxmlformats.org/drawingml/2006/main"/>
           <a:p xmlns:a="http://schemas.openxmlformats.org/drawingml/2006/main">
             <a:pPr>
+              <a:buNone/>
               <a:defRPr sz="2400" b="1">
                 <a:solidFill>
                   <a:srgbClr val="FF9900"/>
@@ -5182,6 +5221,7 @@
           <a:lstStyle xmlns:a="http://schemas.openxmlformats.org/drawingml/2006/main"/>
           <a:p xmlns:a="http://schemas.openxmlformats.org/drawingml/2006/main">
             <a:pPr>
+              <a:buNone/>
               <a:defRPr sz="2325" b="0">
                 <a:solidFill>
                   <a:srgbClr val="FFFFFF"/>
@@ -5239,6 +5279,7 @@
           <a:lstStyle xmlns:a="http://schemas.openxmlformats.org/drawingml/2006/main"/>
           <a:p xmlns:a="http://schemas.openxmlformats.org/drawingml/2006/main">
             <a:pPr>
+              <a:buNone/>
               <a:defRPr sz="2550" b="1">
                 <a:solidFill>
                   <a:srgbClr val="FF9900"/>
@@ -5296,6 +5337,7 @@
           <a:lstStyle xmlns:a="http://schemas.openxmlformats.org/drawingml/2006/main"/>
           <a:p xmlns:a="http://schemas.openxmlformats.org/drawingml/2006/main">
             <a:pPr>
+              <a:buNone/>
               <a:defRPr sz="2025" b="0">
                 <a:solidFill>
                   <a:srgbClr val="FFFFFF"/>
@@ -5319,6 +5361,7 @@
           </a:p>
           <a:p xmlns:a="http://schemas.openxmlformats.org/drawingml/2006/main">
             <a:pPr>
+              <a:buNone/>
               <a:defRPr sz="2025" b="0">
                 <a:solidFill>
                   <a:srgbClr val="FFFFFF"/>
@@ -5376,6 +5419,7 @@
           <a:lstStyle xmlns:a="http://schemas.openxmlformats.org/drawingml/2006/main"/>
           <a:p xmlns:a="http://schemas.openxmlformats.org/drawingml/2006/main">
             <a:pPr>
+              <a:buNone/>
               <a:defRPr sz="1950" b="0">
                 <a:solidFill>
                   <a:srgbClr val="FF9900"/>
@@ -5393,7 +5437,7 @@
                 <a:latin typeface="Arial"/>
                 <a:ea typeface="Arial"/>
                 <a:cs typeface="Arial"/>
-                <a:hlinkClick xmlns:r="http://schemas.openxmlformats.org/officeDocument/2006/relationships" r:id="R37fb99d2950a4731"/>
+                <a:hlinkClick xmlns:r="http://schemas.openxmlformats.org/officeDocument/2006/relationships" r:id="R505cfe657d9c4719"/>
               </a:rPr>
               <a:t>github.com/sebgrtd/rattrapage</a:t>
             </a:r>
@@ -5434,6 +5478,7 @@
           <a:lstStyle xmlns:a="http://schemas.openxmlformats.org/drawingml/2006/main"/>
           <a:p xmlns:a="http://schemas.openxmlformats.org/drawingml/2006/main">
             <a:pPr>
+              <a:buNone/>
               <a:defRPr sz="1875" b="0">
                 <a:solidFill>
                   <a:srgbClr val="B3B3B3"/>
@@ -5520,6 +5565,7 @@
           <a:lstStyle xmlns:a="http://schemas.openxmlformats.org/drawingml/2006/main"/>
           <a:p xmlns:a="http://schemas.openxmlformats.org/drawingml/2006/main">
             <a:pPr>
+              <a:buNone/>
               <a:defRPr sz="3300" b="1">
                 <a:solidFill>
                   <a:srgbClr val="FFFFFF"/>
@@ -5577,6 +5623,7 @@
           <a:lstStyle xmlns:a="http://schemas.openxmlformats.org/drawingml/2006/main"/>
           <a:p xmlns:a="http://schemas.openxmlformats.org/drawingml/2006/main">
             <a:pPr algn="r">
+              <a:buNone/>
               <a:defRPr sz="1425" b="0">
                 <a:solidFill>
                   <a:srgbClr val="B3B3B3"/>
@@ -5602,7 +5649,7 @@
       </p:sp>
       <p:graphicFrame>
         <p:nvGraphicFramePr>
-          <p:cNvPr id="7" name=""/>
+          <p:cNvPr id="9" name=""/>
           <p:cNvGraphicFramePr/>
           <p:nvPr/>
         </p:nvGraphicFramePr>
@@ -6397,6 +6444,7 @@
           <a:lstStyle xmlns:a="http://schemas.openxmlformats.org/drawingml/2006/main"/>
           <a:p xmlns:a="http://schemas.openxmlformats.org/drawingml/2006/main">
             <a:pPr>
+              <a:buNone/>
               <a:defRPr sz="2025" b="0">
                 <a:solidFill>
                   <a:srgbClr val="FF9900"/>
@@ -6483,6 +6531,7 @@
           <a:lstStyle xmlns:a="http://schemas.openxmlformats.org/drawingml/2006/main"/>
           <a:p xmlns:a="http://schemas.openxmlformats.org/drawingml/2006/main">
             <a:pPr>
+              <a:buNone/>
               <a:defRPr sz="3300" b="1">
                 <a:solidFill>
                   <a:srgbClr val="FFFFFF"/>
@@ -6540,6 +6589,7 @@
           <a:lstStyle xmlns:a="http://schemas.openxmlformats.org/drawingml/2006/main"/>
           <a:p xmlns:a="http://schemas.openxmlformats.org/drawingml/2006/main">
             <a:pPr algn="r">
+              <a:buNone/>
               <a:defRPr sz="1425" b="0">
                 <a:solidFill>
                   <a:srgbClr val="B3B3B3"/>
@@ -6597,6 +6647,7 @@
           <a:lstStyle xmlns:a="http://schemas.openxmlformats.org/drawingml/2006/main"/>
           <a:p xmlns:a="http://schemas.openxmlformats.org/drawingml/2006/main">
             <a:pPr>
+              <a:buNone/>
               <a:defRPr sz="2175" b="0">
                 <a:solidFill>
                   <a:srgbClr val="FF9900"/>
@@ -6620,6 +6671,7 @@
           </a:p>
           <a:p xmlns:a="http://schemas.openxmlformats.org/drawingml/2006/main">
             <a:pPr>
+              <a:buNone/>
               <a:defRPr sz="2175" b="0">
                 <a:solidFill>
                   <a:srgbClr val="FF9900"/>
@@ -6643,6 +6695,7 @@
           </a:p>
           <a:p xmlns:a="http://schemas.openxmlformats.org/drawingml/2006/main">
             <a:pPr>
+              <a:buNone/>
               <a:defRPr sz="2175" b="0">
                 <a:solidFill>
                   <a:srgbClr val="FF9900"/>
@@ -6666,6 +6719,7 @@
           </a:p>
           <a:p xmlns:a="http://schemas.openxmlformats.org/drawingml/2006/main">
             <a:pPr>
+              <a:buNone/>
               <a:defRPr sz="2175" b="0">
                 <a:solidFill>
                   <a:srgbClr val="FF9900"/>
@@ -6689,6 +6743,7 @@
           </a:p>
           <a:p xmlns:a="http://schemas.openxmlformats.org/drawingml/2006/main">
             <a:pPr>
+              <a:buNone/>
               <a:defRPr sz="2175" b="0">
                 <a:solidFill>
                   <a:srgbClr val="FF9900"/>
@@ -6712,6 +6767,7 @@
           </a:p>
           <a:p xmlns:a="http://schemas.openxmlformats.org/drawingml/2006/main">
             <a:pPr>
+              <a:buNone/>
               <a:defRPr sz="2175" b="0">
                 <a:solidFill>
                   <a:srgbClr val="FF9900"/>
@@ -6735,6 +6791,7 @@
           </a:p>
           <a:p xmlns:a="http://schemas.openxmlformats.org/drawingml/2006/main">
             <a:pPr>
+              <a:buNone/>
               <a:defRPr sz="2175" b="0">
                 <a:solidFill>
                   <a:srgbClr val="FF9900"/>
@@ -6758,6 +6815,7 @@
           </a:p>
           <a:p xmlns:a="http://schemas.openxmlformats.org/drawingml/2006/main">
             <a:pPr>
+              <a:buNone/>
               <a:defRPr sz="2175" b="0">
                 <a:solidFill>
                   <a:srgbClr val="FF9900"/>
@@ -6781,6 +6839,7 @@
           </a:p>
           <a:p xmlns:a="http://schemas.openxmlformats.org/drawingml/2006/main">
             <a:pPr>
+              <a:buNone/>
               <a:defRPr sz="2175" b="0">
                 <a:solidFill>
                   <a:srgbClr val="FF9900"/>
@@ -6838,6 +6897,7 @@
           <a:lstStyle xmlns:a="http://schemas.openxmlformats.org/drawingml/2006/main"/>
           <a:p xmlns:a="http://schemas.openxmlformats.org/drawingml/2006/main">
             <a:pPr>
+              <a:buNone/>
               <a:defRPr sz="2400" b="1">
                 <a:solidFill>
                   <a:srgbClr val="FFFFFF"/>
@@ -6895,6 +6955,7 @@
           <a:lstStyle xmlns:a="http://schemas.openxmlformats.org/drawingml/2006/main"/>
           <a:p xmlns:a="http://schemas.openxmlformats.org/drawingml/2006/main">
             <a:pPr>
+              <a:buNone/>
               <a:defRPr sz="2175" b="0">
                 <a:solidFill>
                   <a:srgbClr val="B3B3B3"/>
@@ -6918,6 +6979,7 @@
           </a:p>
           <a:p xmlns:a="http://schemas.openxmlformats.org/drawingml/2006/main">
             <a:pPr>
+              <a:buNone/>
               <a:defRPr sz="2175" b="0">
                 <a:solidFill>
                   <a:srgbClr val="B3B3B3"/>
@@ -6975,6 +7037,7 @@
           <a:lstStyle xmlns:a="http://schemas.openxmlformats.org/drawingml/2006/main"/>
           <a:p xmlns:a="http://schemas.openxmlformats.org/drawingml/2006/main">
             <a:pPr>
+              <a:buNone/>
               <a:defRPr sz="2400" b="1">
                 <a:solidFill>
                   <a:srgbClr val="FFFFFF"/>
@@ -7032,6 +7095,7 @@
           <a:lstStyle xmlns:a="http://schemas.openxmlformats.org/drawingml/2006/main"/>
           <a:p xmlns:a="http://schemas.openxmlformats.org/drawingml/2006/main">
             <a:pPr>
+              <a:buNone/>
               <a:defRPr sz="2175" b="0">
                 <a:solidFill>
                   <a:srgbClr val="B3B3B3"/>
@@ -7055,6 +7119,7 @@
           </a:p>
           <a:p xmlns:a="http://schemas.openxmlformats.org/drawingml/2006/main">
             <a:pPr>
+              <a:buNone/>
               <a:defRPr sz="2175" b="0">
                 <a:solidFill>
                   <a:srgbClr val="B3B3B3"/>
@@ -7078,6 +7143,7 @@
           </a:p>
           <a:p xmlns:a="http://schemas.openxmlformats.org/drawingml/2006/main">
             <a:pPr>
+              <a:buNone/>
               <a:defRPr sz="2175" b="0">
                 <a:solidFill>
                   <a:srgbClr val="B3B3B3"/>
@@ -7135,6 +7201,7 @@
           <a:lstStyle xmlns:a="http://schemas.openxmlformats.org/drawingml/2006/main"/>
           <a:p xmlns:a="http://schemas.openxmlformats.org/drawingml/2006/main">
             <a:pPr>
+              <a:buNone/>
               <a:defRPr sz="1875" b="0">
                 <a:solidFill>
                   <a:srgbClr val="FFFFFF"/>
@@ -7221,6 +7288,7 @@
           <a:lstStyle xmlns:a="http://schemas.openxmlformats.org/drawingml/2006/main"/>
           <a:p xmlns:a="http://schemas.openxmlformats.org/drawingml/2006/main">
             <a:pPr>
+              <a:buNone/>
               <a:defRPr sz="3300" b="1">
                 <a:solidFill>
                   <a:srgbClr val="FFFFFF"/>
@@ -7278,6 +7346,7 @@
           <a:lstStyle xmlns:a="http://schemas.openxmlformats.org/drawingml/2006/main"/>
           <a:p xmlns:a="http://schemas.openxmlformats.org/drawingml/2006/main">
             <a:pPr algn="r">
+              <a:buNone/>
               <a:defRPr sz="1425" b="0">
                 <a:solidFill>
                   <a:srgbClr val="B3B3B3"/>
@@ -7303,7 +7372,7 @@
       </p:sp>
       <p:graphicFrame>
         <p:nvGraphicFramePr>
-          <p:cNvPr id="9" name=""/>
+          <p:cNvPr id="11" name=""/>
           <p:cNvGraphicFramePr/>
           <p:nvPr/>
         </p:nvGraphicFramePr>
@@ -7654,6 +7723,7 @@
           <a:lstStyle xmlns:a="http://schemas.openxmlformats.org/drawingml/2006/main"/>
           <a:p xmlns:a="http://schemas.openxmlformats.org/drawingml/2006/main">
             <a:pPr>
+              <a:buNone/>
               <a:defRPr sz="2400" b="1">
                 <a:solidFill>
                   <a:srgbClr val="FF9900"/>
@@ -7711,6 +7781,7 @@
           <a:lstStyle xmlns:a="http://schemas.openxmlformats.org/drawingml/2006/main"/>
           <a:p xmlns:a="http://schemas.openxmlformats.org/drawingml/2006/main">
             <a:pPr>
+              <a:buNone/>
               <a:defRPr sz="2100" b="0">
                 <a:solidFill>
                   <a:srgbClr val="FFFFFF"/>
@@ -7734,6 +7805,7 @@
           </a:p>
           <a:p xmlns:a="http://schemas.openxmlformats.org/drawingml/2006/main">
             <a:pPr>
+              <a:buNone/>
               <a:defRPr sz="2100" b="0">
                 <a:solidFill>
                   <a:srgbClr val="FFFFFF"/>
@@ -7791,6 +7863,7 @@
           <a:lstStyle xmlns:a="http://schemas.openxmlformats.org/drawingml/2006/main"/>
           <a:p xmlns:a="http://schemas.openxmlformats.org/drawingml/2006/main">
             <a:pPr>
+              <a:buNone/>
               <a:defRPr sz="1950" b="0">
                 <a:solidFill>
                   <a:srgbClr val="B3B3B3"/>
@@ -7877,6 +7950,7 @@
           <a:lstStyle xmlns:a="http://schemas.openxmlformats.org/drawingml/2006/main"/>
           <a:p xmlns:a="http://schemas.openxmlformats.org/drawingml/2006/main">
             <a:pPr>
+              <a:buNone/>
               <a:defRPr sz="3300" b="1">
                 <a:solidFill>
                   <a:srgbClr val="FFFFFF"/>
@@ -7934,6 +8008,7 @@
           <a:lstStyle xmlns:a="http://schemas.openxmlformats.org/drawingml/2006/main"/>
           <a:p xmlns:a="http://schemas.openxmlformats.org/drawingml/2006/main">
             <a:pPr algn="r">
+              <a:buNone/>
               <a:defRPr sz="1425" b="0">
                 <a:solidFill>
                   <a:srgbClr val="B3B3B3"/>
@@ -7991,6 +8066,7 @@
           <a:lstStyle xmlns:a="http://schemas.openxmlformats.org/drawingml/2006/main"/>
           <a:p xmlns:a="http://schemas.openxmlformats.org/drawingml/2006/main">
             <a:pPr>
+              <a:buNone/>
               <a:defRPr sz="2850" b="0">
                 <a:solidFill>
                   <a:srgbClr val="FFFFFF"/>
@@ -8014,6 +8090,7 @@
           </a:p>
           <a:p xmlns:a="http://schemas.openxmlformats.org/drawingml/2006/main">
             <a:pPr>
+              <a:buNone/>
               <a:defRPr sz="2850" b="0">
                 <a:solidFill>
                   <a:srgbClr val="FFFFFF"/>
@@ -8071,6 +8148,7 @@
           <a:lstStyle xmlns:a="http://schemas.openxmlformats.org/drawingml/2006/main"/>
           <a:p xmlns:a="http://schemas.openxmlformats.org/drawingml/2006/main">
             <a:pPr>
+              <a:buNone/>
               <a:defRPr sz="7500" b="1">
                 <a:solidFill>
                   <a:srgbClr val="FF9900"/>
@@ -8128,6 +8206,7 @@
           <a:lstStyle xmlns:a="http://schemas.openxmlformats.org/drawingml/2006/main"/>
           <a:p xmlns:a="http://schemas.openxmlformats.org/drawingml/2006/main">
             <a:pPr>
+              <a:buNone/>
               <a:defRPr sz="2100" b="0">
                 <a:solidFill>
                   <a:srgbClr val="FFFFFF"/>
@@ -8185,6 +8264,7 @@
           <a:lstStyle xmlns:a="http://schemas.openxmlformats.org/drawingml/2006/main"/>
           <a:p xmlns:a="http://schemas.openxmlformats.org/drawingml/2006/main">
             <a:pPr>
+              <a:buNone/>
               <a:defRPr sz="7500" b="1">
                 <a:solidFill>
                   <a:srgbClr val="FF9900"/>
@@ -8242,6 +8322,7 @@
           <a:lstStyle xmlns:a="http://schemas.openxmlformats.org/drawingml/2006/main"/>
           <a:p xmlns:a="http://schemas.openxmlformats.org/drawingml/2006/main">
             <a:pPr>
+              <a:buNone/>
               <a:defRPr sz="2100" b="0">
                 <a:solidFill>
                   <a:srgbClr val="FFFFFF"/>
@@ -8299,6 +8380,7 @@
           <a:lstStyle xmlns:a="http://schemas.openxmlformats.org/drawingml/2006/main"/>
           <a:p xmlns:a="http://schemas.openxmlformats.org/drawingml/2006/main">
             <a:pPr>
+              <a:buNone/>
               <a:defRPr sz="7500" b="1">
                 <a:solidFill>
                   <a:srgbClr val="FF9900"/>
@@ -8356,6 +8438,7 @@
           <a:lstStyle xmlns:a="http://schemas.openxmlformats.org/drawingml/2006/main"/>
           <a:p xmlns:a="http://schemas.openxmlformats.org/drawingml/2006/main">
             <a:pPr>
+              <a:buNone/>
               <a:defRPr sz="2100" b="0">
                 <a:solidFill>
                   <a:srgbClr val="FFFFFF"/>
@@ -8413,6 +8496,7 @@
           <a:lstStyle xmlns:a="http://schemas.openxmlformats.org/drawingml/2006/main"/>
           <a:p xmlns:a="http://schemas.openxmlformats.org/drawingml/2006/main">
             <a:pPr>
+              <a:buNone/>
               <a:defRPr sz="2025" b="0">
                 <a:solidFill>
                   <a:srgbClr val="B3B3B3"/>
@@ -8499,6 +8583,7 @@
           <a:lstStyle xmlns:a="http://schemas.openxmlformats.org/drawingml/2006/main"/>
           <a:p xmlns:a="http://schemas.openxmlformats.org/drawingml/2006/main">
             <a:pPr>
+              <a:buNone/>
               <a:defRPr sz="3300" b="1">
                 <a:solidFill>
                   <a:srgbClr val="FFFFFF"/>
@@ -8556,6 +8641,7 @@
           <a:lstStyle xmlns:a="http://schemas.openxmlformats.org/drawingml/2006/main"/>
           <a:p xmlns:a="http://schemas.openxmlformats.org/drawingml/2006/main">
             <a:pPr algn="r">
+              <a:buNone/>
               <a:defRPr sz="1425" b="0">
                 <a:solidFill>
                   <a:srgbClr val="B3B3B3"/>
@@ -8581,7 +8667,7 @@
       </p:sp>
       <p:graphicFrame>
         <p:nvGraphicFramePr>
-          <p:cNvPr id="7" name=""/>
+          <p:cNvPr id="9" name=""/>
           <p:cNvGraphicFramePr/>
           <p:nvPr/>
         </p:nvGraphicFramePr>
@@ -9080,6 +9166,7 @@
           <a:lstStyle xmlns:a="http://schemas.openxmlformats.org/drawingml/2006/main"/>
           <a:p xmlns:a="http://schemas.openxmlformats.org/drawingml/2006/main">
             <a:pPr>
+              <a:buNone/>
               <a:defRPr sz="1950" b="0">
                 <a:solidFill>
                   <a:srgbClr val="B3B3B3"/>
@@ -9166,6 +9253,7 @@
           <a:lstStyle xmlns:a="http://schemas.openxmlformats.org/drawingml/2006/main"/>
           <a:p xmlns:a="http://schemas.openxmlformats.org/drawingml/2006/main">
             <a:pPr>
+              <a:buNone/>
               <a:defRPr sz="3300" b="1">
                 <a:solidFill>
                   <a:srgbClr val="FFFFFF"/>
@@ -9223,6 +9311,7 @@
           <a:lstStyle xmlns:a="http://schemas.openxmlformats.org/drawingml/2006/main"/>
           <a:p xmlns:a="http://schemas.openxmlformats.org/drawingml/2006/main">
             <a:pPr algn="r">
+              <a:buNone/>
               <a:defRPr sz="1425" b="0">
                 <a:solidFill>
                   <a:srgbClr val="B3B3B3"/>
@@ -9280,6 +9369,7 @@
           <a:lstStyle xmlns:a="http://schemas.openxmlformats.org/drawingml/2006/main"/>
           <a:p xmlns:a="http://schemas.openxmlformats.org/drawingml/2006/main">
             <a:pPr>
+              <a:buNone/>
               <a:defRPr sz="5400" b="1">
                 <a:solidFill>
                   <a:srgbClr val="FF9900"/>
@@ -9337,6 +9427,7 @@
           <a:lstStyle xmlns:a="http://schemas.openxmlformats.org/drawingml/2006/main"/>
           <a:p xmlns:a="http://schemas.openxmlformats.org/drawingml/2006/main">
             <a:pPr>
+              <a:buNone/>
               <a:defRPr sz="2325" b="0">
                 <a:solidFill>
                   <a:srgbClr val="FFFFFF"/>
@@ -9394,6 +9485,7 @@
           <a:lstStyle xmlns:a="http://schemas.openxmlformats.org/drawingml/2006/main"/>
           <a:p xmlns:a="http://schemas.openxmlformats.org/drawingml/2006/main">
             <a:pPr>
+              <a:buNone/>
               <a:defRPr sz="2325" b="0">
                 <a:solidFill>
                   <a:srgbClr val="B3B3B3"/>
@@ -9417,6 +9509,7 @@
           </a:p>
           <a:p xmlns:a="http://schemas.openxmlformats.org/drawingml/2006/main">
             <a:pPr>
+              <a:buNone/>
               <a:defRPr sz="2325" b="0">
                 <a:solidFill>
                   <a:srgbClr val="B3B3B3"/>
@@ -9440,6 +9533,7 @@
           </a:p>
           <a:p xmlns:a="http://schemas.openxmlformats.org/drawingml/2006/main">
             <a:pPr>
+              <a:buNone/>
               <a:defRPr sz="2325" b="0">
                 <a:solidFill>
                   <a:srgbClr val="B3B3B3"/>
@@ -9465,7 +9559,7 @@
       </p:sp>
       <p:graphicFrame>
         <p:nvGraphicFramePr>
-          <p:cNvPr id="13" name=""/>
+          <p:cNvPr id="15" name=""/>
           <p:cNvGraphicFramePr/>
           <p:nvPr/>
         </p:nvGraphicFramePr>
@@ -9816,6 +9910,7 @@
           <a:lstStyle xmlns:a="http://schemas.openxmlformats.org/drawingml/2006/main"/>
           <a:p xmlns:a="http://schemas.openxmlformats.org/drawingml/2006/main">
             <a:pPr>
+              <a:buNone/>
               <a:defRPr sz="2100" b="0">
                 <a:solidFill>
                   <a:srgbClr val="FFFFFF"/>
@@ -9902,6 +9997,7 @@
           <a:lstStyle xmlns:a="http://schemas.openxmlformats.org/drawingml/2006/main"/>
           <a:p xmlns:a="http://schemas.openxmlformats.org/drawingml/2006/main">
             <a:pPr>
+              <a:buNone/>
               <a:defRPr sz="3300" b="1">
                 <a:solidFill>
                   <a:srgbClr val="FFFFFF"/>
@@ -9959,6 +10055,7 @@
           <a:lstStyle xmlns:a="http://schemas.openxmlformats.org/drawingml/2006/main"/>
           <a:p xmlns:a="http://schemas.openxmlformats.org/drawingml/2006/main">
             <a:pPr algn="r">
+              <a:buNone/>
               <a:defRPr sz="1425" b="0">
                 <a:solidFill>
                   <a:srgbClr val="B3B3B3"/>
@@ -9984,7 +10081,7 @@
       </p:sp>
       <p:graphicFrame>
         <p:nvGraphicFramePr>
-          <p:cNvPr id="8" name=""/>
+          <p:cNvPr id="10" name=""/>
           <p:cNvGraphicFramePr/>
           <p:nvPr/>
         </p:nvGraphicFramePr>
@@ -10530,6 +10627,7 @@
           <a:lstStyle xmlns:a="http://schemas.openxmlformats.org/drawingml/2006/main"/>
           <a:p xmlns:a="http://schemas.openxmlformats.org/drawingml/2006/main">
             <a:pPr>
+              <a:buNone/>
               <a:defRPr sz="2250" b="0">
                 <a:solidFill>
                   <a:srgbClr val="FF9900"/>
@@ -10587,6 +10685,7 @@
           <a:lstStyle xmlns:a="http://schemas.openxmlformats.org/drawingml/2006/main"/>
           <a:p xmlns:a="http://schemas.openxmlformats.org/drawingml/2006/main">
             <a:pPr>
+              <a:buNone/>
               <a:defRPr sz="1950" b="0">
                 <a:solidFill>
                   <a:srgbClr val="B3B3B3"/>
@@ -10673,6 +10772,7 @@
           <a:lstStyle xmlns:a="http://schemas.openxmlformats.org/drawingml/2006/main"/>
           <a:p xmlns:a="http://schemas.openxmlformats.org/drawingml/2006/main">
             <a:pPr>
+              <a:buNone/>
               <a:defRPr sz="3300" b="1">
                 <a:solidFill>
                   <a:srgbClr val="FFFFFF"/>
@@ -10730,6 +10830,7 @@
           <a:lstStyle xmlns:a="http://schemas.openxmlformats.org/drawingml/2006/main"/>
           <a:p xmlns:a="http://schemas.openxmlformats.org/drawingml/2006/main">
             <a:pPr algn="r">
+              <a:buNone/>
               <a:defRPr sz="1425" b="0">
                 <a:solidFill>
                   <a:srgbClr val="B3B3B3"/>
@@ -10755,7 +10856,7 @@
       </p:sp>
       <p:graphicFrame>
         <p:nvGraphicFramePr>
-          <p:cNvPr id="7" name=""/>
+          <p:cNvPr id="9" name=""/>
           <p:cNvGraphicFramePr/>
           <p:nvPr/>
         </p:nvGraphicFramePr>
@@ -11180,6 +11281,7 @@
           <a:lstStyle xmlns:a="http://schemas.openxmlformats.org/drawingml/2006/main"/>
           <a:p xmlns:a="http://schemas.openxmlformats.org/drawingml/2006/main">
             <a:pPr>
+              <a:buNone/>
               <a:defRPr sz="2175" b="0">
                 <a:solidFill>
                   <a:srgbClr val="FF9900"/>
@@ -11266,6 +11368,7 @@
           <a:lstStyle xmlns:a="http://schemas.openxmlformats.org/drawingml/2006/main"/>
           <a:p xmlns:a="http://schemas.openxmlformats.org/drawingml/2006/main">
             <a:pPr>
+              <a:buNone/>
               <a:defRPr sz="3300" b="1">
                 <a:solidFill>
                   <a:srgbClr val="FFFFFF"/>
@@ -11323,6 +11426,7 @@
           <a:lstStyle xmlns:a="http://schemas.openxmlformats.org/drawingml/2006/main"/>
           <a:p xmlns:a="http://schemas.openxmlformats.org/drawingml/2006/main">
             <a:pPr algn="r">
+              <a:buNone/>
               <a:defRPr sz="1425" b="0">
                 <a:solidFill>
                   <a:srgbClr val="B3B3B3"/>
@@ -11380,6 +11484,7 @@
           <a:lstStyle xmlns:a="http://schemas.openxmlformats.org/drawingml/2006/main"/>
           <a:p xmlns:a="http://schemas.openxmlformats.org/drawingml/2006/main">
             <a:pPr>
+              <a:buNone/>
               <a:defRPr sz="2100" b="0">
                 <a:solidFill>
                   <a:srgbClr val="B3B3B3"/>
@@ -11405,14 +11510,14 @@
       </p:sp>
       <p:pic>
         <p:nvPicPr>
-          <p:cNvPr id="9" name=""/>
+          <p:cNvPr id="11" name=""/>
           <p:cNvPicPr>
             <a:picLocks xmlns:a="http://schemas.openxmlformats.org/drawingml/2006/main" noChangeAspect="1"/>
           </p:cNvPicPr>
           <p:nvPr/>
         </p:nvPicPr>
         <p:blipFill>
-          <a:blip xmlns:r="http://schemas.openxmlformats.org/officeDocument/2006/relationships" xmlns:a="http://schemas.openxmlformats.org/drawingml/2006/main" r:embed="Re2e0ea0ad67a4bf8"/>
+          <a:blip xmlns:r="http://schemas.openxmlformats.org/officeDocument/2006/relationships" xmlns:a="http://schemas.openxmlformats.org/drawingml/2006/main" r:embed="Ra176817b6e514cd0"/>
           <a:srcRect xmlns:a="http://schemas.openxmlformats.org/drawingml/2006/main" l="7970" t="20400" r="2930" b="31000"/>
           <a:stretch xmlns:a="http://schemas.openxmlformats.org/drawingml/2006/main"/>
         </p:blipFill>
@@ -11460,6 +11565,7 @@
           <a:lstStyle xmlns:a="http://schemas.openxmlformats.org/drawingml/2006/main"/>
           <a:p xmlns:a="http://schemas.openxmlformats.org/drawingml/2006/main">
             <a:pPr>
+              <a:buNone/>
               <a:defRPr sz="1650" b="0">
                 <a:solidFill>
                   <a:srgbClr val="B3B3B3"/>
@@ -11546,6 +11652,7 @@
           <a:lstStyle xmlns:a="http://schemas.openxmlformats.org/drawingml/2006/main"/>
           <a:p xmlns:a="http://schemas.openxmlformats.org/drawingml/2006/main">
             <a:pPr>
+              <a:buNone/>
               <a:defRPr sz="3300" b="1">
                 <a:solidFill>
                   <a:srgbClr val="FFFFFF"/>
@@ -11603,6 +11710,7 @@
           <a:lstStyle xmlns:a="http://schemas.openxmlformats.org/drawingml/2006/main"/>
           <a:p xmlns:a="http://schemas.openxmlformats.org/drawingml/2006/main">
             <a:pPr algn="r">
+              <a:buNone/>
               <a:defRPr sz="1425" b="0">
                 <a:solidFill>
                   <a:srgbClr val="B3B3B3"/>
@@ -11628,14 +11736,14 @@
       </p:sp>
       <p:pic>
         <p:nvPicPr>
-          <p:cNvPr id="9" name=""/>
+          <p:cNvPr id="11" name=""/>
           <p:cNvPicPr>
             <a:picLocks xmlns:a="http://schemas.openxmlformats.org/drawingml/2006/main" noChangeAspect="1"/>
           </p:cNvPicPr>
           <p:nvPr/>
         </p:nvPicPr>
         <p:blipFill>
-          <a:blip xmlns:r="http://schemas.openxmlformats.org/officeDocument/2006/relationships" xmlns:a="http://schemas.openxmlformats.org/drawingml/2006/main" r:embed="R1c8fd49f85f34a3e"/>
+          <a:blip xmlns:r="http://schemas.openxmlformats.org/officeDocument/2006/relationships" xmlns:a="http://schemas.openxmlformats.org/drawingml/2006/main" r:embed="R4ef4b2269ae444db"/>
           <a:stretch xmlns:a="http://schemas.openxmlformats.org/drawingml/2006/main"/>
         </p:blipFill>
         <p:spPr>
@@ -11682,6 +11790,7 @@
           <a:lstStyle xmlns:a="http://schemas.openxmlformats.org/drawingml/2006/main"/>
           <a:p xmlns:a="http://schemas.openxmlformats.org/drawingml/2006/main">
             <a:pPr>
+              <a:buNone/>
               <a:defRPr sz="2550" b="1">
                 <a:solidFill>
                   <a:srgbClr val="FF9900"/>
@@ -11705,6 +11814,7 @@
           </a:p>
           <a:p xmlns:a="http://schemas.openxmlformats.org/drawingml/2006/main">
             <a:pPr>
+              <a:buNone/>
               <a:defRPr sz="2550" b="1">
                 <a:solidFill>
                   <a:srgbClr val="FF9900"/>
@@ -11762,6 +11872,7 @@
           <a:lstStyle xmlns:a="http://schemas.openxmlformats.org/drawingml/2006/main"/>
           <a:p xmlns:a="http://schemas.openxmlformats.org/drawingml/2006/main">
             <a:pPr>
+              <a:buNone/>
               <a:defRPr sz="2100" b="0">
                 <a:solidFill>
                   <a:srgbClr val="FFFFFF"/>
@@ -11785,6 +11896,7 @@
           </a:p>
           <a:p xmlns:a="http://schemas.openxmlformats.org/drawingml/2006/main">
             <a:pPr>
+              <a:buNone/>
               <a:defRPr sz="2100" b="0">
                 <a:solidFill>
                   <a:srgbClr val="FFFFFF"/>
@@ -11808,6 +11920,7 @@
           </a:p>
           <a:p xmlns:a="http://schemas.openxmlformats.org/drawingml/2006/main">
             <a:pPr>
+              <a:buNone/>
               <a:defRPr sz="2100" b="0">
                 <a:solidFill>
                   <a:srgbClr val="FFFFFF"/>
@@ -11831,6 +11944,7 @@
           </a:p>
           <a:p xmlns:a="http://schemas.openxmlformats.org/drawingml/2006/main">
             <a:pPr>
+              <a:buNone/>
               <a:defRPr sz="2100" b="0">
                 <a:solidFill>
                   <a:srgbClr val="FFFFFF"/>
@@ -11888,6 +12002,7 @@
           <a:lstStyle xmlns:a="http://schemas.openxmlformats.org/drawingml/2006/main"/>
           <a:p xmlns:a="http://schemas.openxmlformats.org/drawingml/2006/main">
             <a:pPr>
+              <a:buNone/>
               <a:defRPr sz="2175" b="0">
                 <a:solidFill>
                   <a:srgbClr val="FF9900"/>
@@ -11974,6 +12089,7 @@
           <a:lstStyle xmlns:a="http://schemas.openxmlformats.org/drawingml/2006/main"/>
           <a:p xmlns:a="http://schemas.openxmlformats.org/drawingml/2006/main">
             <a:pPr>
+              <a:buNone/>
               <a:defRPr sz="3300" b="1">
                 <a:solidFill>
                   <a:srgbClr val="FFFFFF"/>
@@ -12031,6 +12147,7 @@
           <a:lstStyle xmlns:a="http://schemas.openxmlformats.org/drawingml/2006/main"/>
           <a:p xmlns:a="http://schemas.openxmlformats.org/drawingml/2006/main">
             <a:pPr algn="r">
+              <a:buNone/>
               <a:defRPr sz="1425" b="0">
                 <a:solidFill>
                   <a:srgbClr val="B3B3B3"/>
@@ -12088,6 +12205,7 @@
           <a:lstStyle xmlns:a="http://schemas.openxmlformats.org/drawingml/2006/main"/>
           <a:p xmlns:a="http://schemas.openxmlformats.org/drawingml/2006/main">
             <a:pPr>
+              <a:buNone/>
               <a:defRPr sz="3300" b="1">
                 <a:solidFill>
                   <a:srgbClr val="FF9900"/>
@@ -12145,6 +12263,7 @@
           <a:lstStyle xmlns:a="http://schemas.openxmlformats.org/drawingml/2006/main"/>
           <a:p xmlns:a="http://schemas.openxmlformats.org/drawingml/2006/main">
             <a:pPr>
+              <a:buNone/>
               <a:defRPr sz="2025" b="0">
                 <a:solidFill>
                   <a:srgbClr val="FFFFFF"/>
@@ -12202,6 +12321,7 @@
           <a:lstStyle xmlns:a="http://schemas.openxmlformats.org/drawingml/2006/main"/>
           <a:p xmlns:a="http://schemas.openxmlformats.org/drawingml/2006/main">
             <a:pPr>
+              <a:buNone/>
               <a:defRPr sz="3300" b="1">
                 <a:solidFill>
                   <a:srgbClr val="FF9900"/>
@@ -12259,6 +12379,7 @@
           <a:lstStyle xmlns:a="http://schemas.openxmlformats.org/drawingml/2006/main"/>
           <a:p xmlns:a="http://schemas.openxmlformats.org/drawingml/2006/main">
             <a:pPr>
+              <a:buNone/>
               <a:defRPr sz="2025" b="0">
                 <a:solidFill>
                   <a:srgbClr val="FFFFFF"/>
@@ -12316,6 +12437,7 @@
           <a:lstStyle xmlns:a="http://schemas.openxmlformats.org/drawingml/2006/main"/>
           <a:p xmlns:a="http://schemas.openxmlformats.org/drawingml/2006/main">
             <a:pPr>
+              <a:buNone/>
               <a:defRPr sz="3300" b="1">
                 <a:solidFill>
                   <a:srgbClr val="FF9900"/>
@@ -12373,6 +12495,7 @@
           <a:lstStyle xmlns:a="http://schemas.openxmlformats.org/drawingml/2006/main"/>
           <a:p xmlns:a="http://schemas.openxmlformats.org/drawingml/2006/main">
             <a:pPr>
+              <a:buNone/>
               <a:defRPr sz="2025" b="0">
                 <a:solidFill>
                   <a:srgbClr val="FFFFFF"/>
@@ -12430,6 +12553,7 @@
           <a:lstStyle xmlns:a="http://schemas.openxmlformats.org/drawingml/2006/main"/>
           <a:p xmlns:a="http://schemas.openxmlformats.org/drawingml/2006/main">
             <a:pPr>
+              <a:buNone/>
               <a:defRPr sz="3300" b="1">
                 <a:solidFill>
                   <a:srgbClr val="FF9900"/>
@@ -12487,6 +12611,7 @@
           <a:lstStyle xmlns:a="http://schemas.openxmlformats.org/drawingml/2006/main"/>
           <a:p xmlns:a="http://schemas.openxmlformats.org/drawingml/2006/main">
             <a:pPr>
+              <a:buNone/>
               <a:defRPr sz="2025" b="0">
                 <a:solidFill>
                   <a:srgbClr val="FFFFFF"/>
@@ -12512,14 +12637,14 @@
       </p:sp>
       <p:pic>
         <p:nvPicPr>
-          <p:cNvPr id="23" name=""/>
+          <p:cNvPr id="25" name=""/>
           <p:cNvPicPr>
             <a:picLocks xmlns:a="http://schemas.openxmlformats.org/drawingml/2006/main" noChangeAspect="1"/>
           </p:cNvPicPr>
           <p:nvPr/>
         </p:nvPicPr>
         <p:blipFill>
-          <a:blip xmlns:r="http://schemas.openxmlformats.org/officeDocument/2006/relationships" xmlns:a="http://schemas.openxmlformats.org/drawingml/2006/main" r:embed="Ra95ca70c6a0d4dbe"/>
+          <a:blip xmlns:r="http://schemas.openxmlformats.org/officeDocument/2006/relationships" xmlns:a="http://schemas.openxmlformats.org/drawingml/2006/main" r:embed="Recb7f8fe467e4082"/>
           <a:srcRect xmlns:a="http://schemas.openxmlformats.org/drawingml/2006/main" l="10500" t="41900" r="10500" b="20000"/>
           <a:stretch xmlns:a="http://schemas.openxmlformats.org/drawingml/2006/main"/>
         </p:blipFill>
@@ -12567,6 +12692,7 @@
           <a:lstStyle xmlns:a="http://schemas.openxmlformats.org/drawingml/2006/main"/>
           <a:p xmlns:a="http://schemas.openxmlformats.org/drawingml/2006/main">
             <a:pPr>
+              <a:buNone/>
               <a:defRPr sz="1875" b="0">
                 <a:solidFill>
                   <a:srgbClr val="B3B3B3"/>

</xml_diff>